<commit_message>
Add problem-statement slide to webinar deck (now 15 slides)
Inserts 'Everyone competes on the cheapest quote — who are we pricing to?' as the
framing hook after the agenda, with speaker notes.

Co-Authored-By: Claude Opus 4.8 <noreply@anthropic.com>
</commit_message>
<xml_diff>
--- a/deck/insurance_pricing_webinar.pptx
+++ b/deck/insurance_pricing_webinar.pptx
@@ -19,6 +19,7 @@
     <p:sldId id="267" r:id="rId19"/>
     <p:sldId id="268" r:id="rId20"/>
     <p:sldId id="269" r:id="rId21"/>
+    <p:sldId id="270" r:id="rId22"/>
   </p:sldIdLst>
   <p:sldSz cx="12191695" cy="6858000" type="screen4x3"/>
   <p:notesSz cx="6858000" cy="9144000"/>
@@ -585,7 +586,7 @@
           <a:lstStyle/>
           <a:p>
             <a:r>
-              <a:t>Three ways to price. Compete on the cheapest quote; blanket-upsell everyone; or aim per shopper. The engine lifts revenue per shopper about 6.7%, and conversion goes up, not down — because it holds the price-driven on the lean quote so they don't walk, and trades the coverage-lovers up. Notice the split: price-driven basically left alone, coverage-driven up nearly 12%.</a:t>
+              <a:t>We don't just make up the elasticity. We calibrate it to published auto-insurance figures — price-driven shoppers around minus two, coverage-lovers around minus one-half — and then we sweep it from half to one-and-a-half times. The lift holds between 5.5 and 8.2% across the whole range. That's the difference between a calibrated simulator and a flattering guess.</a:t>
             </a:r>
           </a:p>
         </p:txBody>
@@ -655,7 +656,7 @@
           <a:lstStyle/>
           <a:p>
             <a:r>
-              <a:t>In the real world you don't know a shopper's elasticity up front — you learn it from clicks. Push a price-driven shopper to richer coverage and conversion falls; push a coverage-driven one and it rises. Same offer, opposite result. A Thompson Sampling bandit finds each segment's best offer on its own, converging to within half a percent of a perfect-knowledge oracle.</a:t>
+              <a:t>Three ways to price. Compete on the cheapest quote; blanket-upsell everyone; or aim per shopper. The engine lifts revenue per shopper about 6.7%, and conversion goes up, not down — because it holds the price-driven on the lean quote so they don't walk, and trades the coverage-lovers up. Notice the split: price-driven basically left alone, coverage-driven up nearly 12%.</a:t>
             </a:r>
           </a:p>
         </p:txBody>
@@ -725,7 +726,7 @@
           <a:lstStyle/>
           <a:p>
             <a:r>
-              <a:t>How would this ship? In production it's a streaming loop. Every quote and click flows through Kinesis; a decision service — API Gateway and Lambda with the posteriors in DynamoDB — picks the offer in milliseconds; Flink folds conversions back in near-real-time; Firehose lands events in S3 for dashboards and a nightly SageMaker retrain. To be clear, this is a blueprint — the build itself ran offline on a laptop.</a:t>
+              <a:t>In the real world you don't know a shopper's elasticity up front — you learn it from clicks. Push a price-driven shopper to richer coverage and conversion falls; push a coverage-driven one and it rises. Same offer, opposite result. A Thompson Sampling bandit finds each segment's best offer on its own, converging to within half a percent of a perfect-knowledge oracle.</a:t>
             </a:r>
           </a:p>
         </p:txBody>
@@ -795,7 +796,7 @@
           <a:lstStyle/>
           <a:p>
             <a:r>
-              <a:t>Four things to take home. Heterogeneity is the whole game — 'the customer' is a fiction. The lift comes from not pushing the price-sensitive and trading up the coverage-driven. You can learn elasticity online, cheaply. And show the seam: labeling the modeled layer is what makes the rest believable.</a:t>
+              <a:t>How would this ship? In production it's a streaming loop. Every quote and click flows through Kinesis; a decision service — API Gateway and Lambda with the posteriors in DynamoDB — picks the offer in milliseconds; Flink folds conversions back in near-real-time; Firehose lands events in S3 for dashboards and a nightly SageMaker retrain. To be clear, this is a blueprint — the build itself ran offline on a laptop.</a:t>
             </a:r>
           </a:p>
         </p:txBody>
@@ -865,6 +866,76 @@
           <a:lstStyle/>
           <a:p>
             <a:r>
+              <a:t>Four things to take home. Heterogeneity is the whole game — 'the customer' is a fiction. The lift comes from not pushing the price-sensitive and trading up the coverage-driven. You can learn elasticity online, cheaply. And show the seam: labeling the modeled layer is what makes the rest believable.</a:t>
+            </a:r>
+          </a:p>
+        </p:txBody>
+      </p:sp>
+      <p:sp>
+        <p:nvSpPr>
+          <p:cNvPr id="4" name="Slide Number Placeholder 3"/>
+          <p:cNvSpPr>
+            <a:spLocks noGrp="1"/>
+          </p:cNvSpPr>
+          <p:nvPr>
+            <p:ph type="sldNum" idx="5" sz="quarter"/>
+          </p:nvPr>
+        </p:nvSpPr>
+        <p:spPr/>
+      </p:sp>
+    </p:spTree>
+  </p:cSld>
+  <p:clrMapOvr>
+    <a:masterClrMapping/>
+  </p:clrMapOvr>
+</p:notes>
+</file>
+
+<file path=ppt/notesSlides/notesSlide15.xml><?xml version="1.0" encoding="utf-8"?>
+<p:notes xmlns:a="http://schemas.openxmlformats.org/drawingml/2006/main" xmlns:p="http://schemas.openxmlformats.org/presentationml/2006/main" xmlns:r="http://schemas.openxmlformats.org/officeDocument/2006/relationships">
+  <p:cSld>
+    <p:spTree>
+      <p:nvGrpSpPr>
+        <p:cNvPr id="1" name=""/>
+        <p:cNvGrpSpPr/>
+        <p:nvPr/>
+      </p:nvGrpSpPr>
+      <p:grpSpPr>
+        <a:xfrm>
+          <a:off x="0" y="0"/>
+          <a:ext cx="0" cy="0"/>
+          <a:chOff x="0" y="0"/>
+          <a:chExt cx="0" cy="0"/>
+        </a:xfrm>
+      </p:grpSpPr>
+      <p:sp>
+        <p:nvSpPr>
+          <p:cNvPr id="2" name="Slide Image Placeholder 1"/>
+          <p:cNvSpPr>
+            <a:spLocks noGrp="1"/>
+          </p:cNvSpPr>
+          <p:nvPr>
+            <p:ph type="sldImg" idx="2"/>
+          </p:nvPr>
+        </p:nvSpPr>
+        <p:spPr/>
+      </p:sp>
+      <p:sp>
+        <p:nvSpPr>
+          <p:cNvPr id="3" name="Notes Placeholder 2"/>
+          <p:cNvSpPr>
+            <a:spLocks noGrp="1"/>
+          </p:cNvSpPr>
+          <p:nvPr>
+            <p:ph type="body" idx="3" sz="quarter"/>
+          </p:nvPr>
+        </p:nvSpPr>
+        <p:spPr/>
+        <p:txBody>
+          <a:bodyPr/>
+          <a:lstStyle/>
+          <a:p>
+            <a:r>
               <a:t>That's the build. It's real data, open code, the elasticity swept, and the one simulated layer labeled. The repo and an interactive walkthrough are on screen. Happy to take questions — including the obvious one about deploying this against a live book with a real conversion signal.</a:t>
             </a:r>
           </a:p>
@@ -1005,7 +1076,7 @@
           <a:lstStyle/>
           <a:p>
             <a:r>
-              <a:t>Every square is a real person shopping for car insurance. Only about a quarter bought the cheapest option they saw. Nearly half traded up to richer coverage and paid more. Same quote engine, two completely different shoppers — and if you lead with the cheapest quote for everyone, you're discounting to the half who'd have paid more.</a:t>
+              <a:t>Start with the framing. Every insurer competes on the cheapest quote — but 'the customer' is a fiction. When you price to the average, you hand a discount to the people who would happily have paid more, and you still lose the ones who won't pay up. So the real question isn't 'what's our price?' — it's 'who are we pricing to?' Everything that follows is about answering that from data.</a:t>
             </a:r>
           </a:p>
         </p:txBody>
@@ -1075,7 +1146,7 @@
           <a:lstStyle/>
           <a:p>
             <a:r>
-              <a:t>The credibility rests on the data. This is the Allstate Purchase Prediction dataset — real quote sessions, real coverage bundles A through G, real premiums, a median of six quotes each. Crucially, note the last point: everyone in this data bought something. So it cannot tell us who would have walked away at a higher price. Hold that thought.</a:t>
+              <a:t>Every square is a real person shopping for car insurance. Only about a quarter bought the cheapest option they saw. Nearly half traded up to richer coverage and paid more. Same quote engine, two completely different shoppers — and if you lead with the cheapest quote for everyone, you're discounting to the half who'd have paid more.</a:t>
             </a:r>
           </a:p>
         </p:txBody>
@@ -1145,7 +1216,7 @@
           <a:lstStyle/>
           <a:p>
             <a:r>
-              <a:t>To explain the choices we fit a Bayesian conditional logit. Price pushes people toward cheaper; coverage pulls them richer. And price sensitivity isn't one number — it's sharper for homeowners and young drivers, and it flips for expensive cars. It predicts the bought offer 42% of the time, versus 26 and 39 for the naive baselines.</a:t>
+              <a:t>The credibility rests on the data. This is the Allstate Purchase Prediction dataset — real quote sessions, real coverage bundles A through G, real premiums, a median of six quotes each. Crucially, note the last point: everyone in this data bought something. So it cannot tell us who would have walked away at a higher price. Hold that thought.</a:t>
             </a:r>
           </a:p>
         </p:txBody>
@@ -1215,7 +1286,7 @@
           <a:lstStyle/>
           <a:p>
             <a:r>
-              <a:t>Why Bayesian rather than a plain regression? The Laplace posterior gives each coefficient a full distribution, so we get credible intervals. The price coefficient is minus 0.60, and the interval clearly excludes zero. A pricing committee needs the range and the confidence, not just a point estimate — this reports how sure we are.</a:t>
+              <a:t>To explain the choices we fit a Bayesian conditional logit. Price pushes people toward cheaper; coverage pulls them richer. And price sensitivity isn't one number — it's sharper for homeowners and young drivers, and it flips for expensive cars. It predicts the bought offer 42% of the time, versus 26 and 39 for the naive baselines.</a:t>
             </a:r>
           </a:p>
         </p:txBody>
@@ -1285,7 +1356,7 @@
           <a:lstStyle/>
           <a:p>
             <a:r>
-              <a:t>Split people by what they actually bought and three populations fall out: price-driven, coverage-driven, and balanced in between. They don't want the same thing — the coverage-driven buy 62% of max coverage versus 53% for the price-driven. So why would you quote them the same way?</a:t>
+              <a:t>Why Bayesian rather than a plain regression? The Laplace posterior gives each coefficient a full distribution, so we get credible intervals. The price coefficient is minus 0.60, and the interval clearly excludes zero. A pricing committee needs the range and the confidence, not just a point estimate — this reports how sure we are.</a:t>
             </a:r>
           </a:p>
         </p:txBody>
@@ -1355,7 +1426,7 @@
           <a:lstStyle/>
           <a:p>
             <a:r>
-              <a:t>Now the honest part, before a single dollar of lift. Because the data is buyers-only, we can't observe walk-away. So we add it: a conversion model, and we label it clearly. The shoppers, menus, preferences and segments are real; the walk-away response is a disclosed model. Everything past here is lift in simulation — not a claim about Allstate's revenue.</a:t>
+              <a:t>Split people by what they actually bought and three populations fall out: price-driven, coverage-driven, and balanced in between. They don't want the same thing — the coverage-driven buy 62% of max coverage versus 53% for the price-driven. So why would you quote them the same way?</a:t>
             </a:r>
           </a:p>
         </p:txBody>
@@ -1425,7 +1496,7 @@
           <a:lstStyle/>
           <a:p>
             <a:r>
-              <a:t>We don't just make up the elasticity. We calibrate it to published auto-insurance figures — price-driven shoppers around minus two, coverage-lovers around minus one-half — and then we sweep it from half to one-and-a-half times. The lift holds between 5.5 and 8.2% across the whole range. That's the difference between a calibrated simulator and a flattering guess.</a:t>
+              <a:t>Now the honest part, before a single dollar of lift. Because the data is buyers-only, we can't observe walk-away. So we add it: a conversion model, and we label it clearly. The shoppers, menus, preferences and segments are real; the walk-away response is a disclosed model. Everything past here is lift in simulation — not a claim about Allstate's revenue.</a:t>
             </a:r>
           </a:p>
         </p:txBody>
@@ -4644,6 +4715,48 @@
       <p:pic>
         <p:nvPicPr>
           <p:cNvPr id="2" name="Picture 1" descr="slide_13.png"/>
+          <p:cNvPicPr>
+            <a:picLocks noChangeAspect="1"/>
+          </p:cNvPicPr>
+          <p:nvPr/>
+        </p:nvPicPr>
+        <p:blipFill>
+          <a:blip r:embed="rId2"/>
+          <a:stretch>
+            <a:fillRect/>
+          </a:stretch>
+        </p:blipFill>
+        <p:spPr>
+          <a:xfrm>
+            <a:off x="0" y="0"/>
+            <a:ext cx="12191695" cy="6858000"/>
+          </a:xfrm>
+          <a:prstGeom prst="rect">
+            <a:avLst/>
+          </a:prstGeom>
+        </p:spPr>
+      </p:pic>
+    </p:spTree>
+  </p:cSld>
+  <p:clrMapOvr>
+    <a:masterClrMapping/>
+  </p:clrMapOvr>
+</p:sld>
+</file>
+
+<file path=ppt/slides/slide15.xml><?xml version="1.0" encoding="utf-8"?>
+<p:sld xmlns:a="http://schemas.openxmlformats.org/drawingml/2006/main" xmlns:p="http://schemas.openxmlformats.org/presentationml/2006/main" xmlns:r="http://schemas.openxmlformats.org/officeDocument/2006/relationships">
+  <p:cSld>
+    <p:spTree>
+      <p:nvGrpSpPr>
+        <p:cNvPr id="1" name=""/>
+        <p:cNvGrpSpPr/>
+        <p:nvPr/>
+      </p:nvGrpSpPr>
+      <p:grpSpPr/>
+      <p:pic>
+        <p:nvPicPr>
+          <p:cNvPr id="2" name="Picture 1" descr="slide_14.png"/>
           <p:cNvPicPr>
             <a:picLocks noChangeAspect="1"/>
           </p:cNvPicPr>

</xml_diff>

<commit_message>
Deck: weave in the journey story (17 slides)
Adds three journey slides matching journey.html: (1) the 4-step loop — how the engine
prices a shopper it's never seen (lookalikes -> test offers -> read clicks -> steer &
price), with 'the catch' that demographics guess coverage but only clicks find price
sensitivity; (2) three shoppers, three moves — Dana/Sam/Carla with steered tier +
dynamic price (-$30 / holds / +$90); (3) dynamic pricing = the premium off the list.
Replaces the abstract 'three ways to price' slide, updates the agenda, regenerates the
.pptx and the HTML deck.

Co-Authored-By: Claude Opus 4.8 <noreply@anthropic.com>
</commit_message>
<xml_diff>
--- a/deck/insurance_pricing_webinar.pptx
+++ b/deck/insurance_pricing_webinar.pptx
@@ -20,6 +20,8 @@
     <p:sldId id="268" r:id="rId20"/>
     <p:sldId id="269" r:id="rId21"/>
     <p:sldId id="270" r:id="rId22"/>
+    <p:sldId id="271" r:id="rId23"/>
+    <p:sldId id="272" r:id="rId24"/>
   </p:sldIdLst>
   <p:sldSz cx="12191695" cy="6858000" type="screen4x3"/>
   <p:notesSz cx="6858000" cy="9144000"/>
@@ -656,7 +658,7 @@
           <a:lstStyle/>
           <a:p>
             <a:r>
-              <a:t>Three ways to price. Compete on the cheapest quote; blanket-upsell everyone; or aim per shopper. The engine lifts revenue per shopper about 6.7%, and conversion goes up, not down — because it holds the price-driven on the lean quote so they don't walk, and trades the coverage-lovers up. Notice the split: price-driven basically left alone, coverage-driven up nearly 12%.</a:t>
+              <a:t>Here's how the engine prices a shopper it's never seen. Step one: look up what real lookalikes bought — a warm start on coverage. Step two: float a few test offers. Step three: read the clicks. Step four: steer the coverage and set the price. The catch is the whole point — demographics can guess the coverage, but only the clicks reveal who'll walk on price.</a:t>
             </a:r>
           </a:p>
         </p:txBody>
@@ -726,7 +728,7 @@
           <a:lstStyle/>
           <a:p>
             <a:r>
-              <a:t>In the real world you don't know a shopper's elasticity up front — you learn it from clicks. Push a price-driven shopper to richer coverage and conversion falls; push a coverage-driven one and it rises. Same offer, opposite result. A Thompson Sampling bandit finds each segment's best offer on its own, converging to within half a percent of a perfect-knowledge oracle.</a:t>
+              <a:t>Watch it run on three real profiles. Dana, a young renter, clicks the cheapest option — she's price-driven, so the engine steers her to Basic and prices it DOWN, $551 to $521, to win a sale she'd otherwise walk from. Carla, an older homeowner, reaches for full coverage — steered to Full and priced UP, $673 to $763, because she'll pay. Sam is in between: he takes the standard plan, and the engine holds at the list price. Same engine, three different moves.</a:t>
             </a:r>
           </a:p>
         </p:txBody>
@@ -796,7 +798,7 @@
           <a:lstStyle/>
           <a:p>
             <a:r>
-              <a:t>How would this ship? In production it's a streaming loop. Every quote and click flows through Kinesis; a decision service — API Gateway and Lambda with the posteriors in DynamoDB — picks the offer in milliseconds; Flink folds conversions back in near-real-time; Firehose lands events in S3 for dashboards and a nightly SageMaker retrain. To be clear, this is a blueprint — the build itself ran offline on a laptop.</a:t>
+              <a:t>This is where the dynamic pricing actually happens. It's not the tier — those list prices are cost-based. It's the personalized premium the engine sets on the tier the shopper wants: a discount to convert the price-sensitive, a markup for the coverage-lover who'll pay, and — for the balanced middle — no move at all. Personalization pays most at the extremes; in the middle, the standard price is already right. That's the honest shape of it.</a:t>
             </a:r>
           </a:p>
         </p:txBody>
@@ -866,7 +868,7 @@
           <a:lstStyle/>
           <a:p>
             <a:r>
-              <a:t>Four things to take home. Heterogeneity is the whole game — 'the customer' is a fiction. The lift comes from not pushing the price-sensitive and trading up the coverage-driven. You can learn elasticity online, cheaply. And show the seam: labeling the modeled layer is what makes the rest believable.</a:t>
+              <a:t>In the real world you don't know a shopper's elasticity up front — you learn it from clicks. Push a price-driven shopper to richer coverage and conversion falls; push a coverage-driven one and it rises. Same offer, opposite result. A Thompson Sampling bandit finds each segment's best offer on its own, converging to within half a percent of a perfect-knowledge oracle.</a:t>
             </a:r>
           </a:p>
         </p:txBody>
@@ -892,6 +894,146 @@
 </file>
 
 <file path=ppt/notesSlides/notesSlide15.xml><?xml version="1.0" encoding="utf-8"?>
+<p:notes xmlns:a="http://schemas.openxmlformats.org/drawingml/2006/main" xmlns:p="http://schemas.openxmlformats.org/presentationml/2006/main" xmlns:r="http://schemas.openxmlformats.org/officeDocument/2006/relationships">
+  <p:cSld>
+    <p:spTree>
+      <p:nvGrpSpPr>
+        <p:cNvPr id="1" name=""/>
+        <p:cNvGrpSpPr/>
+        <p:nvPr/>
+      </p:nvGrpSpPr>
+      <p:grpSpPr>
+        <a:xfrm>
+          <a:off x="0" y="0"/>
+          <a:ext cx="0" cy="0"/>
+          <a:chOff x="0" y="0"/>
+          <a:chExt cx="0" cy="0"/>
+        </a:xfrm>
+      </p:grpSpPr>
+      <p:sp>
+        <p:nvSpPr>
+          <p:cNvPr id="2" name="Slide Image Placeholder 1"/>
+          <p:cNvSpPr>
+            <a:spLocks noGrp="1"/>
+          </p:cNvSpPr>
+          <p:nvPr>
+            <p:ph type="sldImg" idx="2"/>
+          </p:nvPr>
+        </p:nvSpPr>
+        <p:spPr/>
+      </p:sp>
+      <p:sp>
+        <p:nvSpPr>
+          <p:cNvPr id="3" name="Notes Placeholder 2"/>
+          <p:cNvSpPr>
+            <a:spLocks noGrp="1"/>
+          </p:cNvSpPr>
+          <p:nvPr>
+            <p:ph type="body" idx="3" sz="quarter"/>
+          </p:nvPr>
+        </p:nvSpPr>
+        <p:spPr/>
+        <p:txBody>
+          <a:bodyPr/>
+          <a:lstStyle/>
+          <a:p>
+            <a:r>
+              <a:t>How would this ship? In production it's a streaming loop. Every quote and click flows through Kinesis; a decision service — API Gateway and Lambda with the posteriors in DynamoDB — picks the offer in milliseconds; Flink folds conversions back in near-real-time; Firehose lands events in S3 for dashboards and a nightly SageMaker retrain. To be clear, this is a blueprint — the build itself ran offline on a laptop.</a:t>
+            </a:r>
+          </a:p>
+        </p:txBody>
+      </p:sp>
+      <p:sp>
+        <p:nvSpPr>
+          <p:cNvPr id="4" name="Slide Number Placeholder 3"/>
+          <p:cNvSpPr>
+            <a:spLocks noGrp="1"/>
+          </p:cNvSpPr>
+          <p:nvPr>
+            <p:ph type="sldNum" idx="5" sz="quarter"/>
+          </p:nvPr>
+        </p:nvSpPr>
+        <p:spPr/>
+      </p:sp>
+    </p:spTree>
+  </p:cSld>
+  <p:clrMapOvr>
+    <a:masterClrMapping/>
+  </p:clrMapOvr>
+</p:notes>
+</file>
+
+<file path=ppt/notesSlides/notesSlide16.xml><?xml version="1.0" encoding="utf-8"?>
+<p:notes xmlns:a="http://schemas.openxmlformats.org/drawingml/2006/main" xmlns:p="http://schemas.openxmlformats.org/presentationml/2006/main" xmlns:r="http://schemas.openxmlformats.org/officeDocument/2006/relationships">
+  <p:cSld>
+    <p:spTree>
+      <p:nvGrpSpPr>
+        <p:cNvPr id="1" name=""/>
+        <p:cNvGrpSpPr/>
+        <p:nvPr/>
+      </p:nvGrpSpPr>
+      <p:grpSpPr>
+        <a:xfrm>
+          <a:off x="0" y="0"/>
+          <a:ext cx="0" cy="0"/>
+          <a:chOff x="0" y="0"/>
+          <a:chExt cx="0" cy="0"/>
+        </a:xfrm>
+      </p:grpSpPr>
+      <p:sp>
+        <p:nvSpPr>
+          <p:cNvPr id="2" name="Slide Image Placeholder 1"/>
+          <p:cNvSpPr>
+            <a:spLocks noGrp="1"/>
+          </p:cNvSpPr>
+          <p:nvPr>
+            <p:ph type="sldImg" idx="2"/>
+          </p:nvPr>
+        </p:nvSpPr>
+        <p:spPr/>
+      </p:sp>
+      <p:sp>
+        <p:nvSpPr>
+          <p:cNvPr id="3" name="Notes Placeholder 2"/>
+          <p:cNvSpPr>
+            <a:spLocks noGrp="1"/>
+          </p:cNvSpPr>
+          <p:nvPr>
+            <p:ph type="body" idx="3" sz="quarter"/>
+          </p:nvPr>
+        </p:nvSpPr>
+        <p:spPr/>
+        <p:txBody>
+          <a:bodyPr/>
+          <a:lstStyle/>
+          <a:p>
+            <a:r>
+              <a:t>Four things to take home. Heterogeneity is the whole game — 'the customer' is a fiction. The lift comes from not pushing the price-sensitive and trading up the coverage-driven. You can learn elasticity online, cheaply. And show the seam: labeling the modeled layer is what makes the rest believable.</a:t>
+            </a:r>
+          </a:p>
+        </p:txBody>
+      </p:sp>
+      <p:sp>
+        <p:nvSpPr>
+          <p:cNvPr id="4" name="Slide Number Placeholder 3"/>
+          <p:cNvSpPr>
+            <a:spLocks noGrp="1"/>
+          </p:cNvSpPr>
+          <p:nvPr>
+            <p:ph type="sldNum" idx="5" sz="quarter"/>
+          </p:nvPr>
+        </p:nvSpPr>
+        <p:spPr/>
+      </p:sp>
+    </p:spTree>
+  </p:cSld>
+  <p:clrMapOvr>
+    <a:masterClrMapping/>
+  </p:clrMapOvr>
+</p:notes>
+</file>
+
+<file path=ppt/notesSlides/notesSlide17.xml><?xml version="1.0" encoding="utf-8"?>
 <p:notes xmlns:a="http://schemas.openxmlformats.org/drawingml/2006/main" xmlns:p="http://schemas.openxmlformats.org/presentationml/2006/main" xmlns:r="http://schemas.openxmlformats.org/officeDocument/2006/relationships">
   <p:cSld>
     <p:spTree>
@@ -4757,6 +4899,90 @@
       <p:pic>
         <p:nvPicPr>
           <p:cNvPr id="2" name="Picture 1" descr="slide_14.png"/>
+          <p:cNvPicPr>
+            <a:picLocks noChangeAspect="1"/>
+          </p:cNvPicPr>
+          <p:nvPr/>
+        </p:nvPicPr>
+        <p:blipFill>
+          <a:blip r:embed="rId2"/>
+          <a:stretch>
+            <a:fillRect/>
+          </a:stretch>
+        </p:blipFill>
+        <p:spPr>
+          <a:xfrm>
+            <a:off x="0" y="0"/>
+            <a:ext cx="12191695" cy="6858000"/>
+          </a:xfrm>
+          <a:prstGeom prst="rect">
+            <a:avLst/>
+          </a:prstGeom>
+        </p:spPr>
+      </p:pic>
+    </p:spTree>
+  </p:cSld>
+  <p:clrMapOvr>
+    <a:masterClrMapping/>
+  </p:clrMapOvr>
+</p:sld>
+</file>
+
+<file path=ppt/slides/slide16.xml><?xml version="1.0" encoding="utf-8"?>
+<p:sld xmlns:a="http://schemas.openxmlformats.org/drawingml/2006/main" xmlns:p="http://schemas.openxmlformats.org/presentationml/2006/main" xmlns:r="http://schemas.openxmlformats.org/officeDocument/2006/relationships">
+  <p:cSld>
+    <p:spTree>
+      <p:nvGrpSpPr>
+        <p:cNvPr id="1" name=""/>
+        <p:cNvGrpSpPr/>
+        <p:nvPr/>
+      </p:nvGrpSpPr>
+      <p:grpSpPr/>
+      <p:pic>
+        <p:nvPicPr>
+          <p:cNvPr id="2" name="Picture 1" descr="slide_15.png"/>
+          <p:cNvPicPr>
+            <a:picLocks noChangeAspect="1"/>
+          </p:cNvPicPr>
+          <p:nvPr/>
+        </p:nvPicPr>
+        <p:blipFill>
+          <a:blip r:embed="rId2"/>
+          <a:stretch>
+            <a:fillRect/>
+          </a:stretch>
+        </p:blipFill>
+        <p:spPr>
+          <a:xfrm>
+            <a:off x="0" y="0"/>
+            <a:ext cx="12191695" cy="6858000"/>
+          </a:xfrm>
+          <a:prstGeom prst="rect">
+            <a:avLst/>
+          </a:prstGeom>
+        </p:spPr>
+      </p:pic>
+    </p:spTree>
+  </p:cSld>
+  <p:clrMapOvr>
+    <a:masterClrMapping/>
+  </p:clrMapOvr>
+</p:sld>
+</file>
+
+<file path=ppt/slides/slide17.xml><?xml version="1.0" encoding="utf-8"?>
+<p:sld xmlns:a="http://schemas.openxmlformats.org/drawingml/2006/main" xmlns:p="http://schemas.openxmlformats.org/presentationml/2006/main" xmlns:r="http://schemas.openxmlformats.org/officeDocument/2006/relationships">
+  <p:cSld>
+    <p:spTree>
+      <p:nvGrpSpPr>
+        <p:cNvPr id="1" name=""/>
+        <p:cNvGrpSpPr/>
+        <p:nvPr/>
+      </p:nvGrpSpPr>
+      <p:grpSpPr/>
+      <p:pic>
+        <p:nvPicPr>
+          <p:cNvPr id="2" name="Picture 1" descr="slide_16.png"/>
           <p:cNvPicPr>
             <a:picLocks noChangeAspect="1"/>
           </p:cNvPicPr>

</xml_diff>